<commit_message>
wip: chart setter fixes + examples regeneration
</commit_message>
<xml_diff>
--- a/examples/ppt/animations.pptx
+++ b/examples/ppt/animations.pptx
@@ -5,12 +5,12 @@
     <p:sldMasterId xmlns:r="http://schemas.openxmlformats.org/officeDocument/2006/relationships" id="2147483648" r:id="rId1"/>
   </p:sldMasterIdLst>
   <p:sldIdLst>
-    <p:sldId id="256" r:id="R7c2ff62878e24cbe"/>
-    <p:sldId id="257" r:id="R0c1eaeacf5464855"/>
-    <p:sldId id="258" r:id="Rccd7cc62e42f42d0"/>
-    <p:sldId id="259" r:id="Rb8e44bba4f2c4e36"/>
-    <p:sldId id="260" r:id="R526b5a5c720b4ed1"/>
-    <p:sldId id="261" r:id="Rdb589eb0535e4cfc"/>
+    <p:sldId id="256" r:id="R391d5042e60843ca"/>
+    <p:sldId id="257" r:id="R2a3fa7f232f74e75"/>
+    <p:sldId id="258" r:id="R7997b1dab75d442b"/>
+    <p:sldId id="259" r:id="Rc491e24c33134296"/>
+    <p:sldId id="260" r:id="R3db01a83a9814872"/>
+    <p:sldId id="261" r:id="Rda816efe49e44593"/>
   </p:sldIdLst>
   <p:sldSz cx="12192000" cy="6858000"/>
   <p:notesSz cx="6858000" cy="9144000"/>
@@ -73,7 +73,7 @@
             <a:spLocks xmlns:a="http://schemas.openxmlformats.org/drawingml/2006/main" noGrp="1"/>
           </p:cNvSpPr>
           <p:nvPr>
-            <p:ph type="subTitle"/>
+            <p:ph type="subTitle" idx="1"/>
           </p:nvPr>
         </p:nvSpPr>
         <p:spPr>
@@ -136,7 +136,7 @@
             <a:spLocks xmlns:a="http://schemas.openxmlformats.org/drawingml/2006/main" noGrp="1"/>
           </p:cNvSpPr>
           <p:nvPr>
-            <p:ph type="body"/>
+            <p:ph type="body" idx="1"/>
           </p:nvPr>
         </p:nvSpPr>
         <p:spPr>
@@ -199,7 +199,7 @@
             <a:spLocks xmlns:a="http://schemas.openxmlformats.org/drawingml/2006/main" noGrp="1"/>
           </p:cNvSpPr>
           <p:nvPr>
-            <p:ph type="body"/>
+            <p:ph type="body" idx="1"/>
           </p:nvPr>
         </p:nvSpPr>
         <p:spPr>
@@ -223,7 +223,7 @@
             <a:spLocks xmlns:a="http://schemas.openxmlformats.org/drawingml/2006/main" noGrp="1"/>
           </p:cNvSpPr>
           <p:nvPr>
-            <p:ph type="body"/>
+            <p:ph type="body" idx="2"/>
           </p:nvPr>
         </p:nvSpPr>
         <p:spPr>
@@ -285,7 +285,7 @@
 </file>
 
 <file path=ppt/slideMasters/slideMaster1.xml><?xml version="1.0" encoding="utf-8"?>
-<p:sldMaster xmlns:p="http://schemas.openxmlformats.org/presentationml/2006/main">
+<p:sldMaster xmlns:r="http://schemas.openxmlformats.org/officeDocument/2006/relationships" xmlns:p="http://schemas.openxmlformats.org/presentationml/2006/main">
   <p:cSld>
     <p:spTree>
       <p:nvGrpSpPr>
@@ -355,13 +355,14 @@
           <a:lstStyle xmlns:a="http://schemas.openxmlformats.org/drawingml/2006/main"/>
           <a:p xmlns:a="http://schemas.openxmlformats.org/drawingml/2006/main">
             <a:r>
-              <a:rPr sz="4800">
+              <a:rPr lang="en-US" sz="4800">
                 <a:solidFill>
                   <a:srgbClr val="FFFFFF"/>
                 </a:solidFill>
               </a:rPr>
               <a:t>Animation Showcase</a:t>
             </a:r>
+            <a:endParaRPr lang="en-US"/>
           </a:p>
         </p:txBody>
       </p:sp>
@@ -372,7 +373,7 @@
             <a:spLocks xmlns:a="http://schemas.openxmlformats.org/drawingml/2006/main" noGrp="1"/>
           </p:cNvSpPr>
           <p:nvPr>
-            <p:ph type="subTitle"/>
+            <p:ph type="subTitle" idx="1"/>
           </p:nvPr>
         </p:nvSpPr>
         <p:spPr>
@@ -386,13 +387,14 @@
           <a:lstStyle xmlns:a="http://schemas.openxmlformats.org/drawingml/2006/main"/>
           <a:p xmlns:a="http://schemas.openxmlformats.org/drawingml/2006/main">
             <a:r>
-              <a:rPr sz="2200">
+              <a:rPr lang="en-US" sz="2200">
                 <a:solidFill>
                   <a:srgbClr val="85C1E9"/>
                 </a:solidFill>
               </a:rPr>
               <a:t>Every animation effect in officecli</a:t>
             </a:r>
+            <a:endParaRPr lang="en-US"/>
           </a:p>
         </p:txBody>
       </p:sp>
@@ -432,7 +434,7 @@
         <p:spPr>
           <a:xfrm xmlns:a="http://schemas.openxmlformats.org/drawingml/2006/main">
             <a:off x="838200" y="365125"/>
-            <a:ext cx="10515600" cy="1325563"/>
+            <a:ext cx="10515600" cy="1320800"/>
           </a:xfrm>
         </p:spPr>
         <p:txBody>
@@ -452,7 +454,7 @@
       </p:sp>
       <p:sp>
         <p:nvSpPr>
-          <p:cNvPr id="10000" name="TextBox 2"/>
+          <p:cNvPr id="100000" name="TextBox 2"/>
           <p:cNvSpPr/>
           <p:nvPr/>
         </p:nvSpPr>
@@ -487,7 +489,7 @@
       </p:sp>
       <p:sp>
         <p:nvSpPr>
-          <p:cNvPr id="10001" name="TextBox 3"/>
+          <p:cNvPr id="100001" name="TextBox 3"/>
           <p:cNvSpPr/>
           <p:nvPr/>
         </p:nvSpPr>
@@ -522,7 +524,7 @@
       </p:sp>
       <p:sp>
         <p:nvSpPr>
-          <p:cNvPr id="10002" name="TextBox 4"/>
+          <p:cNvPr id="100002" name="TextBox 4"/>
           <p:cNvSpPr/>
           <p:nvPr/>
         </p:nvSpPr>
@@ -557,7 +559,7 @@
       </p:sp>
       <p:sp>
         <p:nvSpPr>
-          <p:cNvPr id="10003" name="TextBox 5"/>
+          <p:cNvPr id="100003" name="TextBox 5"/>
           <p:cNvSpPr/>
           <p:nvPr/>
         </p:nvSpPr>
@@ -592,7 +594,7 @@
       </p:sp>
       <p:sp>
         <p:nvSpPr>
-          <p:cNvPr id="10004" name="TextBox 6"/>
+          <p:cNvPr id="100004" name="TextBox 6"/>
           <p:cNvSpPr/>
           <p:nvPr/>
         </p:nvSpPr>
@@ -627,7 +629,7 @@
       </p:sp>
       <p:sp>
         <p:nvSpPr>
-          <p:cNvPr id="10005" name="TextBox 7"/>
+          <p:cNvPr id="100005" name="TextBox 7"/>
           <p:cNvSpPr/>
           <p:nvPr/>
         </p:nvSpPr>
@@ -662,7 +664,7 @@
       </p:sp>
       <p:sp>
         <p:nvSpPr>
-          <p:cNvPr id="10006" name="TextBox 8"/>
+          <p:cNvPr id="100006" name="TextBox 8"/>
           <p:cNvSpPr/>
           <p:nvPr/>
         </p:nvSpPr>
@@ -697,7 +699,7 @@
       </p:sp>
       <p:sp>
         <p:nvSpPr>
-          <p:cNvPr id="10007" name="TextBox 9"/>
+          <p:cNvPr id="100007" name="TextBox 9"/>
           <p:cNvSpPr/>
           <p:nvPr/>
         </p:nvSpPr>
@@ -732,7 +734,7 @@
       </p:sp>
       <p:sp>
         <p:nvSpPr>
-          <p:cNvPr id="10008" name="TextBox 10"/>
+          <p:cNvPr id="100008" name="TextBox 10"/>
           <p:cNvSpPr/>
           <p:nvPr/>
         </p:nvSpPr>
@@ -767,7 +769,7 @@
       </p:sp>
       <p:sp>
         <p:nvSpPr>
-          <p:cNvPr id="10009" name="TextBox 11"/>
+          <p:cNvPr id="100009" name="TextBox 11"/>
           <p:cNvSpPr/>
           <p:nvPr/>
         </p:nvSpPr>
@@ -802,7 +804,7 @@
       </p:sp>
       <p:sp>
         <p:nvSpPr>
-          <p:cNvPr id="10010" name="TextBox 12"/>
+          <p:cNvPr id="100010" name="TextBox 12"/>
           <p:cNvSpPr/>
           <p:nvPr/>
         </p:nvSpPr>
@@ -837,7 +839,7 @@
       </p:sp>
       <p:sp>
         <p:nvSpPr>
-          <p:cNvPr id="10011" name="TextBox 13"/>
+          <p:cNvPr id="100011" name="TextBox 13"/>
           <p:cNvSpPr/>
           <p:nvPr/>
         </p:nvSpPr>
@@ -909,7 +911,7 @@
                                           </p:stCondLst>
                                         </p:cTn>
                                         <p:tgtEl>
-                                          <p:spTgt spid="10000"/>
+                                          <p:spTgt spid="100000"/>
                                         </p:tgtEl>
                                         <p:attrNameLst>
                                           <p:attrName>style.visibility</p:attrName>
@@ -954,7 +956,7 @@
                                           </p:stCondLst>
                                         </p:cTn>
                                         <p:tgtEl>
-                                          <p:spTgt spid="10001"/>
+                                          <p:spTgt spid="100001"/>
                                         </p:tgtEl>
                                         <p:attrNameLst>
                                           <p:attrName>style.visibility</p:attrName>
@@ -968,7 +970,7 @@
                                       <p:cBhvr>
                                         <p:cTn id="11" dur="800"/>
                                         <p:tgtEl>
-                                          <p:spTgt spid="10001"/>
+                                          <p:spTgt spid="100001"/>
                                         </p:tgtEl>
                                       </p:cBhvr>
                                     </p:animEffect>
@@ -1007,7 +1009,7 @@
                                           </p:stCondLst>
                                         </p:cTn>
                                         <p:tgtEl>
-                                          <p:spTgt spid="10002"/>
+                                          <p:spTgt spid="100002"/>
                                         </p:tgtEl>
                                         <p:attrNameLst>
                                           <p:attrName>style.visibility</p:attrName>
@@ -1021,7 +1023,7 @@
                                       <p:cBhvr additive="base">
                                         <p:cTn id="19" dur="600" fill="hold"/>
                                         <p:tgtEl>
-                                          <p:spTgt spid="10002"/>
+                                          <p:spTgt spid="100002"/>
                                         </p:tgtEl>
                                         <p:attrNameLst>
                                           <p:attrName>ppt_y</p:attrName>
@@ -1075,7 +1077,7 @@
                                           </p:stCondLst>
                                         </p:cTn>
                                         <p:tgtEl>
-                                          <p:spTgt spid="10003"/>
+                                          <p:spTgt spid="100003"/>
                                         </p:tgtEl>
                                         <p:attrNameLst>
                                           <p:attrName>style.visibility</p:attrName>
@@ -1089,7 +1091,7 @@
                                       <p:cBhvr>
                                         <p:cTn id="24" dur="700" fill="hold"/>
                                         <p:tgtEl>
-                                          <p:spTgt spid="10003"/>
+                                          <p:spTgt spid="100003"/>
                                         </p:tgtEl>
                                       </p:cBhvr>
                                       <p:from x="0" y="0"/>
@@ -1130,7 +1132,7 @@
                                           </p:stCondLst>
                                         </p:cTn>
                                         <p:tgtEl>
-                                          <p:spTgt spid="10004"/>
+                                          <p:spTgt spid="100004"/>
                                         </p:tgtEl>
                                         <p:attrNameLst>
                                           <p:attrName>style.visibility</p:attrName>
@@ -1144,7 +1146,7 @@
                                       <p:cBhvr>
                                         <p:cTn id="30" dur="600"/>
                                         <p:tgtEl>
-                                          <p:spTgt spid="10004"/>
+                                          <p:spTgt spid="100004"/>
                                         </p:tgtEl>
                                       </p:cBhvr>
                                     </p:animEffect>
@@ -1183,7 +1185,7 @@
                                           </p:stCondLst>
                                         </p:cTn>
                                         <p:tgtEl>
-                                          <p:spTgt spid="10005"/>
+                                          <p:spTgt spid="100005"/>
                                         </p:tgtEl>
                                         <p:attrNameLst>
                                           <p:attrName>style.visibility</p:attrName>
@@ -1228,7 +1230,7 @@
                                           </p:stCondLst>
                                         </p:cTn>
                                         <p:tgtEl>
-                                          <p:spTgt spid="10006"/>
+                                          <p:spTgt spid="100006"/>
                                         </p:tgtEl>
                                         <p:attrNameLst>
                                           <p:attrName>style.visibility</p:attrName>
@@ -1242,7 +1244,7 @@
                                       <p:cBhvr additive="base">
                                         <p:cTn id="44" dur="700" fill="hold"/>
                                         <p:tgtEl>
-                                          <p:spTgt spid="10006"/>
+                                          <p:spTgt spid="100006"/>
                                         </p:tgtEl>
                                         <p:attrNameLst>
                                           <p:attrName>ppt_y</p:attrName>
@@ -1296,7 +1298,7 @@
                                           </p:stCondLst>
                                         </p:cTn>
                                         <p:tgtEl>
-                                          <p:spTgt spid="10007"/>
+                                          <p:spTgt spid="100007"/>
                                         </p:tgtEl>
                                         <p:attrNameLst>
                                           <p:attrName>style.visibility</p:attrName>
@@ -1310,7 +1312,7 @@
                                       <p:cBhvr>
                                         <p:cTn id="49" dur="600"/>
                                         <p:tgtEl>
-                                          <p:spTgt spid="10007"/>
+                                          <p:spTgt spid="100007"/>
                                         </p:tgtEl>
                                       </p:cBhvr>
                                     </p:animEffect>
@@ -1349,7 +1351,7 @@
                                           </p:stCondLst>
                                         </p:cTn>
                                         <p:tgtEl>
-                                          <p:spTgt spid="10008"/>
+                                          <p:spTgt spid="100008"/>
                                         </p:tgtEl>
                                         <p:attrNameLst>
                                           <p:attrName>style.visibility</p:attrName>
@@ -1363,7 +1365,7 @@
                                       <p:cBhvr>
                                         <p:cTn id="55" dur="800"/>
                                         <p:tgtEl>
-                                          <p:spTgt spid="10008"/>
+                                          <p:spTgt spid="100008"/>
                                         </p:tgtEl>
                                       </p:cBhvr>
                                     </p:animEffect>
@@ -1402,7 +1404,7 @@
                                           </p:stCondLst>
                                         </p:cTn>
                                         <p:tgtEl>
-                                          <p:spTgt spid="10009"/>
+                                          <p:spTgt spid="100009"/>
                                         </p:tgtEl>
                                         <p:attrNameLst>
                                           <p:attrName>style.visibility</p:attrName>
@@ -1416,7 +1418,7 @@
                                       <p:cBhvr>
                                         <p:cTn id="61" dur="700" fill="hold"/>
                                         <p:tgtEl>
-                                          <p:spTgt spid="10009"/>
+                                          <p:spTgt spid="100009"/>
                                         </p:tgtEl>
                                       </p:cBhvr>
                                     </p:animRot>
@@ -1424,7 +1426,7 @@
                                       <p:cBhvr>
                                         <p:cTn id="63" dur="700"/>
                                         <p:tgtEl>
-                                          <p:spTgt spid="10009"/>
+                                          <p:spTgt spid="100009"/>
                                         </p:tgtEl>
                                       </p:cBhvr>
                                     </p:animEffect>
@@ -1463,7 +1465,7 @@
                                           </p:stCondLst>
                                         </p:cTn>
                                         <p:tgtEl>
-                                          <p:spTgt spid="10010"/>
+                                          <p:spTgt spid="100010"/>
                                         </p:tgtEl>
                                         <p:attrNameLst>
                                           <p:attrName>style.visibility</p:attrName>
@@ -1477,7 +1479,7 @@
                                       <p:cBhvr>
                                         <p:cTn id="68" dur="600"/>
                                         <p:tgtEl>
-                                          <p:spTgt spid="10010"/>
+                                          <p:spTgt spid="100010"/>
                                         </p:tgtEl>
                                       </p:cBhvr>
                                     </p:animEffect>
@@ -1516,7 +1518,7 @@
                                           </p:stCondLst>
                                         </p:cTn>
                                         <p:tgtEl>
-                                          <p:spTgt spid="10011"/>
+                                          <p:spTgt spid="100011"/>
                                         </p:tgtEl>
                                         <p:attrNameLst>
                                           <p:attrName>style.visibility</p:attrName>
@@ -1530,7 +1532,7 @@
                                       <p:cBhvr>
                                         <p:cTn id="74" dur="600"/>
                                         <p:tgtEl>
-                                          <p:spTgt spid="10011"/>
+                                          <p:spTgt spid="100011"/>
                                         </p:tgtEl>
                                       </p:cBhvr>
                                     </p:animEffect>
@@ -1565,18 +1567,18 @@
       </p:par>
     </p:tnLst>
     <p:bldLst>
-      <p:bldP spid="10000" grpId="0"/>
-      <p:bldP spid="10001" grpId="1"/>
-      <p:bldP spid="10002" grpId="2"/>
-      <p:bldP spid="10003" grpId="3"/>
-      <p:bldP spid="10004" grpId="4"/>
-      <p:bldP spid="10005" grpId="5"/>
-      <p:bldP spid="10006" grpId="6"/>
-      <p:bldP spid="10007" grpId="7"/>
-      <p:bldP spid="10008" grpId="8"/>
-      <p:bldP spid="10009" grpId="9"/>
-      <p:bldP spid="10010" grpId="10"/>
-      <p:bldP spid="10011" grpId="11"/>
+      <p:bldP spid="100000" grpId="0"/>
+      <p:bldP spid="100001" grpId="1"/>
+      <p:bldP spid="100002" grpId="2"/>
+      <p:bldP spid="100003" grpId="3"/>
+      <p:bldP spid="100004" grpId="4"/>
+      <p:bldP spid="100005" grpId="5"/>
+      <p:bldP spid="100006" grpId="6"/>
+      <p:bldP spid="100007" grpId="7"/>
+      <p:bldP spid="100008" grpId="8"/>
+      <p:bldP spid="100009" grpId="9"/>
+      <p:bldP spid="100010" grpId="10"/>
+      <p:bldP spid="100011" grpId="11"/>
     </p:bldLst>
   </p:timing>
 </p:sld>
@@ -1610,7 +1612,7 @@
         <p:spPr>
           <a:xfrm xmlns:a="http://schemas.openxmlformats.org/drawingml/2006/main">
             <a:off x="838200" y="365125"/>
-            <a:ext cx="10515600" cy="1325563"/>
+            <a:ext cx="10515600" cy="1320800"/>
           </a:xfrm>
         </p:spPr>
         <p:txBody>
@@ -1630,7 +1632,7 @@
       </p:sp>
       <p:sp>
         <p:nvSpPr>
-          <p:cNvPr id="10012" name="TextBox 2"/>
+          <p:cNvPr id="100012" name="TextBox 2"/>
           <p:cNvSpPr/>
           <p:nvPr/>
         </p:nvSpPr>
@@ -1665,7 +1667,7 @@
       </p:sp>
       <p:sp>
         <p:nvSpPr>
-          <p:cNvPr id="10013" name="TextBox 3"/>
+          <p:cNvPr id="100013" name="TextBox 3"/>
           <p:cNvSpPr/>
           <p:nvPr/>
         </p:nvSpPr>
@@ -1700,7 +1702,7 @@
       </p:sp>
       <p:sp>
         <p:nvSpPr>
-          <p:cNvPr id="10014" name="TextBox 4"/>
+          <p:cNvPr id="100014" name="TextBox 4"/>
           <p:cNvSpPr/>
           <p:nvPr/>
         </p:nvSpPr>
@@ -1735,7 +1737,7 @@
       </p:sp>
       <p:sp>
         <p:nvSpPr>
-          <p:cNvPr id="10015" name="TextBox 5"/>
+          <p:cNvPr id="100015" name="TextBox 5"/>
           <p:cNvSpPr/>
           <p:nvPr/>
         </p:nvSpPr>
@@ -1770,7 +1772,7 @@
       </p:sp>
       <p:sp>
         <p:nvSpPr>
-          <p:cNvPr id="10016" name="TextBox 6"/>
+          <p:cNvPr id="100016" name="TextBox 6"/>
           <p:cNvSpPr/>
           <p:nvPr/>
         </p:nvSpPr>
@@ -1805,7 +1807,7 @@
       </p:sp>
       <p:sp>
         <p:nvSpPr>
-          <p:cNvPr id="10017" name="TextBox 7"/>
+          <p:cNvPr id="100017" name="TextBox 7"/>
           <p:cNvSpPr/>
           <p:nvPr/>
         </p:nvSpPr>
@@ -1877,7 +1879,7 @@
                                           </p:stCondLst>
                                         </p:cTn>
                                         <p:tgtEl>
-                                          <p:spTgt spid="10012"/>
+                                          <p:spTgt spid="100012"/>
                                         </p:tgtEl>
                                         <p:attrNameLst>
                                           <p:attrName>style.visibility</p:attrName>
@@ -1891,7 +1893,7 @@
                                       <p:cBhvr>
                                         <p:cTn id="5" dur="800"/>
                                         <p:tgtEl>
-                                          <p:spTgt spid="10012"/>
+                                          <p:spTgt spid="100012"/>
                                         </p:tgtEl>
                                       </p:cBhvr>
                                     </p:animEffect>
@@ -1930,7 +1932,7 @@
                                           </p:stCondLst>
                                         </p:cTn>
                                         <p:tgtEl>
-                                          <p:spTgt spid="10013"/>
+                                          <p:spTgt spid="100013"/>
                                         </p:tgtEl>
                                         <p:attrNameLst>
                                           <p:attrName>style.visibility</p:attrName>
@@ -1944,7 +1946,7 @@
                                       <p:cBhvr additive="base">
                                         <p:cTn id="13" dur="600" fill="hold"/>
                                         <p:tgtEl>
-                                          <p:spTgt spid="10013"/>
+                                          <p:spTgt spid="100013"/>
                                         </p:tgtEl>
                                         <p:attrNameLst>
                                           <p:attrName>ppt_y</p:attrName>
@@ -1998,7 +2000,7 @@
                                           </p:stCondLst>
                                         </p:cTn>
                                         <p:tgtEl>
-                                          <p:spTgt spid="10014"/>
+                                          <p:spTgt spid="100014"/>
                                         </p:tgtEl>
                                         <p:attrNameLst>
                                           <p:attrName>style.visibility</p:attrName>
@@ -2012,7 +2014,7 @@
                                       <p:cBhvr>
                                         <p:cTn id="18" dur="700" fill="hold"/>
                                         <p:tgtEl>
-                                          <p:spTgt spid="10014"/>
+                                          <p:spTgt spid="100014"/>
                                         </p:tgtEl>
                                       </p:cBhvr>
                                       <p:from x="100000" y="100000"/>
@@ -2053,7 +2055,7 @@
                                           </p:stCondLst>
                                         </p:cTn>
                                         <p:tgtEl>
-                                          <p:spTgt spid="10015"/>
+                                          <p:spTgt spid="100015"/>
                                         </p:tgtEl>
                                         <p:attrNameLst>
                                           <p:attrName>style.visibility</p:attrName>
@@ -2067,7 +2069,7 @@
                                       <p:cBhvr>
                                         <p:cTn id="24" dur="600"/>
                                         <p:tgtEl>
-                                          <p:spTgt spid="10015"/>
+                                          <p:spTgt spid="100015"/>
                                         </p:tgtEl>
                                       </p:cBhvr>
                                     </p:animEffect>
@@ -2106,7 +2108,7 @@
                                           </p:stCondLst>
                                         </p:cTn>
                                         <p:tgtEl>
-                                          <p:spTgt spid="10016"/>
+                                          <p:spTgt spid="100016"/>
                                         </p:tgtEl>
                                         <p:attrNameLst>
                                           <p:attrName>style.visibility</p:attrName>
@@ -2120,7 +2122,7 @@
                                       <p:cBhvr>
                                         <p:cTn id="30" dur="600"/>
                                         <p:tgtEl>
-                                          <p:spTgt spid="10016"/>
+                                          <p:spTgt spid="100016"/>
                                         </p:tgtEl>
                                       </p:cBhvr>
                                     </p:animEffect>
@@ -2159,7 +2161,7 @@
                                           </p:stCondLst>
                                         </p:cTn>
                                         <p:tgtEl>
-                                          <p:spTgt spid="10017"/>
+                                          <p:spTgt spid="100017"/>
                                         </p:tgtEl>
                                         <p:attrNameLst>
                                           <p:attrName>style.visibility</p:attrName>
@@ -2173,7 +2175,7 @@
                                       <p:cBhvr>
                                         <p:cTn id="36" dur="500"/>
                                         <p:tgtEl>
-                                          <p:spTgt spid="10017"/>
+                                          <p:spTgt spid="100017"/>
                                         </p:tgtEl>
                                       </p:cBhvr>
                                     </p:animEffect>
@@ -2208,12 +2210,12 @@
       </p:par>
     </p:tnLst>
     <p:bldLst>
-      <p:bldP spid="10012" grpId="0"/>
-      <p:bldP spid="10013" grpId="1"/>
-      <p:bldP spid="10014" grpId="2"/>
-      <p:bldP spid="10015" grpId="3"/>
-      <p:bldP spid="10016" grpId="4"/>
-      <p:bldP spid="10017" grpId="5"/>
+      <p:bldP spid="100012" grpId="0"/>
+      <p:bldP spid="100013" grpId="1"/>
+      <p:bldP spid="100014" grpId="2"/>
+      <p:bldP spid="100015" grpId="3"/>
+      <p:bldP spid="100016" grpId="4"/>
+      <p:bldP spid="100017" grpId="5"/>
     </p:bldLst>
   </p:timing>
 </p:sld>
@@ -2247,7 +2249,7 @@
         <p:spPr>
           <a:xfrm xmlns:a="http://schemas.openxmlformats.org/drawingml/2006/main">
             <a:off x="838200" y="365125"/>
-            <a:ext cx="10515600" cy="1325563"/>
+            <a:ext cx="10515600" cy="1320800"/>
           </a:xfrm>
         </p:spPr>
         <p:txBody>
@@ -2267,7 +2269,7 @@
       </p:sp>
       <p:sp>
         <p:nvSpPr>
-          <p:cNvPr id="10018" name="TextBox 2"/>
+          <p:cNvPr id="100018" name="TextBox 2"/>
           <p:cNvSpPr/>
           <p:nvPr/>
         </p:nvSpPr>
@@ -2302,7 +2304,7 @@
       </p:sp>
       <p:sp>
         <p:nvSpPr>
-          <p:cNvPr id="10019" name="TextBox 3"/>
+          <p:cNvPr id="100019" name="TextBox 3"/>
           <p:cNvSpPr/>
           <p:nvPr/>
         </p:nvSpPr>
@@ -2337,7 +2339,7 @@
       </p:sp>
       <p:sp>
         <p:nvSpPr>
-          <p:cNvPr id="10020" name="TextBox 4"/>
+          <p:cNvPr id="100020" name="TextBox 4"/>
           <p:cNvSpPr/>
           <p:nvPr/>
         </p:nvSpPr>
@@ -2372,7 +2374,7 @@
       </p:sp>
       <p:sp>
         <p:nvSpPr>
-          <p:cNvPr id="10021" name="TextBox 5"/>
+          <p:cNvPr id="100021" name="TextBox 5"/>
           <p:cNvSpPr/>
           <p:nvPr/>
         </p:nvSpPr>
@@ -2419,32 +2421,106 @@
               <p:cTn id="2" dur="indefinite" nodeType="mainSeq">
                 <p:childTnLst>
                   <p:par>
-                    <p:cTn id="8" fill="hold">
+                    <p:cTn id="6" fill="hold">
                       <p:stCondLst>
                         <p:cond delay="indefinite"/>
                       </p:stCondLst>
                       <p:childTnLst>
                         <p:par>
-                          <p:cTn id="7" fill="hold">
+                          <p:cTn id="5" fill="hold">
                             <p:stCondLst>
                               <p:cond delay="0"/>
                             </p:stCondLst>
                             <p:childTnLst>
                               <p:par>
-                                <p:cTn id="3" presetID="27" presetClass="emph" presetSubtype="0" dur="1000" fill="hold" grpId="0" nodeType="clickEffect">
+                                <p:cTn id="4" presetID="8" presetClass="emph" presetSubtype="0" dur="1000" fill="hold" grpId="0" nodeType="clickEffect">
+                                  <p:stCondLst>
+                                    <p:cond delay="0"/>
+                                  </p:stCondLst>
+                                  <p:childTnLst xmlns:p="http://schemas.openxmlformats.org/presentationml/2006/main" xmlns:a="http://schemas.openxmlformats.org/drawingml/2006/main" xmlns:r="http://schemas.openxmlformats.org/officeDocument/2006/relationships">
+                                    <p:animRot by="21600000">
+                                      <p:cBhvr>
+                                        <p:cTn id="3" dur="1000" fill="hold"/>
+                                        <p:tgtEl>
+                                          <p:spTgt spid="100018"/>
+                                        </p:tgtEl>
+                                        <p:attrNameLst>
+                                          <p:attrName>r</p:attrName>
+                                        </p:attrNameLst>
+                                      </p:cBhvr>
+                                    </p:animRot>
+                                  </p:childTnLst>
+                                </p:cTn>
+                              </p:par>
+                            </p:childTnLst>
+                          </p:cTn>
+                        </p:par>
+                      </p:childTnLst>
+                    </p:cTn>
+                  </p:par>
+                  <p:par>
+                    <p:cTn id="10" fill="hold">
+                      <p:stCondLst>
+                        <p:cond delay="0"/>
+                      </p:stCondLst>
+                      <p:childTnLst>
+                        <p:par>
+                          <p:cTn id="9" fill="hold">
+                            <p:stCondLst>
+                              <p:cond delay="0"/>
+                            </p:stCondLst>
+                            <p:childTnLst>
+                              <p:par>
+                                <p:cTn id="8" presetID="6" presetClass="emph" presetSubtype="0" dur="800" fill="hold" grpId="1" nodeType="afterEffect">
+                                  <p:stCondLst>
+                                    <p:cond delay="0"/>
+                                  </p:stCondLst>
+                                  <p:childTnLst xmlns:p="http://schemas.openxmlformats.org/presentationml/2006/main" xmlns:a="http://schemas.openxmlformats.org/drawingml/2006/main" xmlns:r="http://schemas.openxmlformats.org/officeDocument/2006/relationships">
+                                    <p:animScale>
+                                      <p:cBhvr>
+                                        <p:cTn id="7" dur="800" fill="hold"/>
+                                        <p:tgtEl>
+                                          <p:spTgt spid="100019"/>
+                                        </p:tgtEl>
+                                      </p:cBhvr>
+                                      <p:by x="150000" y="150000"/>
+                                    </p:animScale>
+                                  </p:childTnLst>
+                                </p:cTn>
+                              </p:par>
+                            </p:childTnLst>
+                          </p:cTn>
+                        </p:par>
+                      </p:childTnLst>
+                    </p:cTn>
+                  </p:par>
+                  <p:par>
+                    <p:cTn id="16" fill="hold">
+                      <p:stCondLst>
+                        <p:cond delay="0"/>
+                      </p:stCondLst>
+                      <p:childTnLst>
+                        <p:par>
+                          <p:cTn id="15" fill="hold">
+                            <p:stCondLst>
+                              <p:cond delay="0"/>
+                            </p:stCondLst>
+                            <p:childTnLst>
+                              <p:par>
+                                <p:cTn id="11" presetID="14" presetClass="emph" presetSubtype="0" dur="700" fill="hold" grpId="2" nodeType="afterEffect">
                                   <p:stCondLst>
                                     <p:cond delay="0"/>
                                   </p:stCondLst>
                                   <p:childTnLst>
                                     <p:set>
                                       <p:cBhvr>
-                                        <p:cTn id="4" dur="1" fill="hold">
+                                        <p:cTn id="12" dur="1" fill="hold">
                                           <p:stCondLst>
                                             <p:cond delay="0"/>
                                           </p:stCondLst>
                                         </p:cTn>
                                         <p:tgtEl>
-                                          <p:spTgt spid="10018"/>
+                                          <p:spTgt spid="100020"/>
                                         </p:tgtEl>
                                         <p:attrNameLst>
                                           <p:attrName>style.visibility</p:attrName>
@@ -2464,129 +2540,63 @@
                     </p:cTn>
                   </p:par>
                   <p:par>
-                    <p:cTn id="14" fill="hold">
+                    <p:cTn id="22" fill="hold">
                       <p:stCondLst>
                         <p:cond delay="0"/>
                       </p:stCondLst>
                       <p:childTnLst>
                         <p:par>
-                          <p:cTn id="13" fill="hold">
+                          <p:cTn id="21" fill="hold">
                             <p:stCondLst>
                               <p:cond delay="0"/>
                             </p:stCondLst>
                             <p:childTnLst>
                               <p:par>
-                                <p:cTn id="9" presetID="26" presetClass="emph" presetSubtype="0" dur="800" fill="hold" grpId="1" nodeType="afterEffect">
+                                <p:cTn id="20" presetID="1" presetClass="emph" presetSubtype="2" dur="500" fill="hold" grpId="3" nodeType="afterEffect">
                                   <p:stCondLst>
                                     <p:cond delay="0"/>
                                   </p:stCondLst>
-                                  <p:childTnLst>
+                                  <p:childTnLst xmlns:p="http://schemas.openxmlformats.org/presentationml/2006/main" xmlns:a="http://schemas.openxmlformats.org/drawingml/2006/main" xmlns:r="http://schemas.openxmlformats.org/officeDocument/2006/relationships">
+                                    <p:animClr clrSpc="rgb" dir="cw">
+                                      <p:cBhvr>
+                                        <p:cTn id="17" dur="500" fill="hold"/>
+                                        <p:tgtEl>
+                                          <p:spTgt spid="100021"/>
+                                        </p:tgtEl>
+                                        <p:attrNameLst>
+                                          <p:attrName>fillcolor</p:attrName>
+                                        </p:attrNameLst>
+                                      </p:cBhvr>
+                                      <p:to>
+                                        <a:schemeClr val="accent2"/>
+                                      </p:to>
+                                    </p:animClr>
                                     <p:set>
                                       <p:cBhvr>
-                                        <p:cTn id="10" dur="1" fill="hold">
-                                          <p:stCondLst>
-                                            <p:cond delay="0"/>
-                                          </p:stCondLst>
-                                        </p:cTn>
-                                        <p:tgtEl>
-                                          <p:spTgt spid="10019"/>
+                                        <p:cTn id="18" dur="2000" fill="hold"/>
+                                        <p:tgtEl>
+                                          <p:spTgt spid="100021"/>
                                         </p:tgtEl>
                                         <p:attrNameLst>
-                                          <p:attrName>style.visibility</p:attrName>
+                                          <p:attrName>fill.type</p:attrName>
                                         </p:attrNameLst>
                                       </p:cBhvr>
                                       <p:to>
-                                        <p:strVal val="visible"/>
+                                        <p:strVal val="solid"/>
                                       </p:to>
                                     </p:set>
-                                  </p:childTnLst>
-                                </p:cTn>
-                              </p:par>
-                            </p:childTnLst>
-                          </p:cTn>
-                        </p:par>
-                      </p:childTnLst>
-                    </p:cTn>
-                  </p:par>
-                  <p:par>
-                    <p:cTn id="20" fill="hold">
-                      <p:stCondLst>
-                        <p:cond delay="0"/>
-                      </p:stCondLst>
-                      <p:childTnLst>
-                        <p:par>
-                          <p:cTn id="19" fill="hold">
-                            <p:stCondLst>
-                              <p:cond delay="0"/>
-                            </p:stCondLst>
-                            <p:childTnLst>
-                              <p:par>
-                                <p:cTn id="15" presetID="14" presetClass="emph" presetSubtype="0" dur="700" fill="hold" grpId="2" nodeType="afterEffect">
-                                  <p:stCondLst>
-                                    <p:cond delay="0"/>
-                                  </p:stCondLst>
-                                  <p:childTnLst>
                                     <p:set>
                                       <p:cBhvr>
-                                        <p:cTn id="16" dur="1" fill="hold">
-                                          <p:stCondLst>
-                                            <p:cond delay="0"/>
-                                          </p:stCondLst>
-                                        </p:cTn>
-                                        <p:tgtEl>
-                                          <p:spTgt spid="10020"/>
+                                        <p:cTn id="19" dur="2000" fill="hold"/>
+                                        <p:tgtEl>
+                                          <p:spTgt spid="100021"/>
                                         </p:tgtEl>
                                         <p:attrNameLst>
-                                          <p:attrName>style.visibility</p:attrName>
+                                          <p:attrName>fill.on</p:attrName>
                                         </p:attrNameLst>
                                       </p:cBhvr>
                                       <p:to>
-                                        <p:strVal val="visible"/>
-                                      </p:to>
-                                    </p:set>
-                                  </p:childTnLst>
-                                </p:cTn>
-                              </p:par>
-                            </p:childTnLst>
-                          </p:cTn>
-                        </p:par>
-                      </p:childTnLst>
-                    </p:cTn>
-                  </p:par>
-                  <p:par>
-                    <p:cTn id="26" fill="hold">
-                      <p:stCondLst>
-                        <p:cond delay="0"/>
-                      </p:stCondLst>
-                      <p:childTnLst>
-                        <p:par>
-                          <p:cTn id="25" fill="hold">
-                            <p:stCondLst>
-                              <p:cond delay="0"/>
-                            </p:stCondLst>
-                            <p:childTnLst>
-                              <p:par>
-                                <p:cTn id="21" presetID="1" presetClass="emph" presetSubtype="0" dur="500" fill="hold" grpId="3" nodeType="afterEffect">
-                                  <p:stCondLst>
-                                    <p:cond delay="0"/>
-                                  </p:stCondLst>
-                                  <p:childTnLst>
-                                    <p:set>
-                                      <p:cBhvr>
-                                        <p:cTn id="22" dur="1" fill="hold">
-                                          <p:stCondLst>
-                                            <p:cond delay="0"/>
-                                          </p:stCondLst>
-                                        </p:cTn>
-                                        <p:tgtEl>
-                                          <p:spTgt spid="10021"/>
-                                        </p:tgtEl>
-                                        <p:attrNameLst>
-                                          <p:attrName>style.visibility</p:attrName>
-                                        </p:attrNameLst>
-                                      </p:cBhvr>
-                                      <p:to>
-                                        <p:strVal val="visible"/>
+                                        <p:strVal val="true"/>
                                       </p:to>
                                     </p:set>
                                   </p:childTnLst>
@@ -2620,10 +2630,10 @@
       </p:par>
     </p:tnLst>
     <p:bldLst>
-      <p:bldP spid="10018" grpId="0"/>
-      <p:bldP spid="10019" grpId="1"/>
-      <p:bldP spid="10020" grpId="2"/>
-      <p:bldP spid="10021" grpId="3"/>
+      <p:bldP spid="100018" grpId="0"/>
+      <p:bldP spid="100019" grpId="1"/>
+      <p:bldP spid="100020" grpId="2"/>
+      <p:bldP spid="100021" grpId="3"/>
     </p:bldLst>
   </p:timing>
 </p:sld>
@@ -2657,7 +2667,7 @@
         <p:spPr>
           <a:xfrm xmlns:a="http://schemas.openxmlformats.org/drawingml/2006/main">
             <a:off x="838200" y="365125"/>
-            <a:ext cx="10515600" cy="1325563"/>
+            <a:ext cx="10515600" cy="1320800"/>
           </a:xfrm>
         </p:spPr>
         <p:txBody>
@@ -2677,7 +2687,7 @@
       </p:sp>
       <p:sp>
         <p:nvSpPr>
-          <p:cNvPr id="10022" name="TextBox 2"/>
+          <p:cNvPr id="100022" name="TextBox 2"/>
           <p:cNvSpPr/>
           <p:nvPr/>
         </p:nvSpPr>
@@ -2717,7 +2727,7 @@
       </p:sp>
       <p:sp>
         <p:nvSpPr>
-          <p:cNvPr id="10023" name="TextBox 3"/>
+          <p:cNvPr id="100023" name="TextBox 3"/>
           <p:cNvSpPr/>
           <p:nvPr/>
         </p:nvSpPr>
@@ -2757,7 +2767,7 @@
       </p:sp>
       <p:sp>
         <p:nvSpPr>
-          <p:cNvPr id="10024" name="TextBox 4"/>
+          <p:cNvPr id="100024" name="TextBox 4"/>
           <p:cNvSpPr/>
           <p:nvPr/>
         </p:nvSpPr>
@@ -2797,7 +2807,7 @@
       </p:sp>
       <p:sp>
         <p:nvSpPr>
-          <p:cNvPr id="10025" name="TextBox 5"/>
+          <p:cNvPr id="100025" name="TextBox 5"/>
           <p:cNvSpPr/>
           <p:nvPr/>
         </p:nvSpPr>
@@ -2837,7 +2847,7 @@
       </p:sp>
       <p:sp>
         <p:nvSpPr>
-          <p:cNvPr id="10026" name="TextBox 6"/>
+          <p:cNvPr id="100026" name="TextBox 6"/>
           <p:cNvSpPr/>
           <p:nvPr/>
         </p:nvSpPr>
@@ -2877,7 +2887,7 @@
       </p:sp>
       <p:sp>
         <p:nvSpPr>
-          <p:cNvPr id="10027" name="TextBox 7"/>
+          <p:cNvPr id="100027" name="TextBox 7"/>
           <p:cNvSpPr/>
           <p:nvPr/>
         </p:nvSpPr>
@@ -2917,7 +2927,7 @@
       </p:sp>
       <p:sp>
         <p:nvSpPr>
-          <p:cNvPr id="10028" name="TextBox 8"/>
+          <p:cNvPr id="100028" name="TextBox 8"/>
           <p:cNvSpPr/>
           <p:nvPr/>
         </p:nvSpPr>
@@ -2957,7 +2967,7 @@
       </p:sp>
       <p:sp>
         <p:nvSpPr>
-          <p:cNvPr id="10029" name="TextBox 9"/>
+          <p:cNvPr id="100029" name="TextBox 9"/>
           <p:cNvSpPr/>
           <p:nvPr/>
         </p:nvSpPr>
@@ -2997,7 +3007,7 @@
       </p:sp>
       <p:sp>
         <p:nvSpPr>
-          <p:cNvPr id="10030" name="TextBox 10"/>
+          <p:cNvPr id="100030" name="TextBox 10"/>
           <p:cNvSpPr/>
           <p:nvPr/>
         </p:nvSpPr>
@@ -3037,7 +3047,7 @@
       </p:sp>
       <p:sp>
         <p:nvSpPr>
-          <p:cNvPr id="10031" name="TextBox 11"/>
+          <p:cNvPr id="100031" name="TextBox 11"/>
           <p:cNvSpPr/>
           <p:nvPr/>
         </p:nvSpPr>
@@ -3077,7 +3087,7 @@
       </p:sp>
       <p:sp>
         <p:nvSpPr>
-          <p:cNvPr id="10032" name="TextBox 12"/>
+          <p:cNvPr id="100032" name="TextBox 12"/>
           <p:cNvSpPr/>
           <p:nvPr/>
         </p:nvSpPr>
@@ -3117,7 +3127,7 @@
       </p:sp>
       <p:sp>
         <p:nvSpPr>
-          <p:cNvPr id="10033" name="TextBox 13"/>
+          <p:cNvPr id="100033" name="TextBox 13"/>
           <p:cNvSpPr/>
           <p:nvPr/>
         </p:nvSpPr>
@@ -3157,7 +3167,7 @@
       </p:sp>
       <p:sp>
         <p:nvSpPr>
-          <p:cNvPr id="10034" name="TextBox 14"/>
+          <p:cNvPr id="100034" name="TextBox 14"/>
           <p:cNvSpPr/>
           <p:nvPr/>
         </p:nvSpPr>
@@ -3198,7 +3208,7 @@
     </p:spTree>
   </p:cSld>
   <p:transition>
-    <p:split orient="horz" dir="in"/>
+    <p:split orient="horz"/>
   </p:transition>
 </p:sld>
 </file>
@@ -3231,7 +3241,7 @@
         <p:spPr>
           <a:xfrm xmlns:a="http://schemas.openxmlformats.org/drawingml/2006/main">
             <a:off x="838200" y="365125"/>
-            <a:ext cx="10515600" cy="1325563"/>
+            <a:ext cx="10515600" cy="1320800"/>
           </a:xfrm>
         </p:spPr>
         <p:txBody>
@@ -3251,7 +3261,7 @@
       </p:sp>
       <p:sp>
         <p:nvSpPr>
-          <p:cNvPr id="10035" name="TextBox 2"/>
+          <p:cNvPr id="100035" name="TextBox 2"/>
           <p:cNvSpPr/>
           <p:nvPr/>
         </p:nvSpPr>
@@ -3298,7 +3308,7 @@
       </p:sp>
       <p:sp>
         <p:nvSpPr>
-          <p:cNvPr id="10036" name="TextBox 3"/>
+          <p:cNvPr id="100036" name="TextBox 3"/>
           <p:cNvSpPr/>
           <p:nvPr/>
         </p:nvSpPr>
@@ -3345,7 +3355,7 @@
       </p:sp>
       <p:sp>
         <p:nvSpPr>
-          <p:cNvPr id="10037" name="TextBox 4"/>
+          <p:cNvPr id="100037" name="TextBox 4"/>
           <p:cNvSpPr/>
           <p:nvPr/>
         </p:nvSpPr>
@@ -3392,7 +3402,7 @@
       </p:sp>
       <p:sp>
         <p:nvSpPr>
-          <p:cNvPr id="10038" name="TextBox 5"/>
+          <p:cNvPr id="100038" name="TextBox 5"/>
           <p:cNvSpPr/>
           <p:nvPr/>
         </p:nvSpPr>
@@ -3427,7 +3437,7 @@
       </p:sp>
       <p:sp>
         <p:nvSpPr>
-          <p:cNvPr id="10039" name="TextBox 6"/>
+          <p:cNvPr id="100039" name="TextBox 6"/>
           <p:cNvSpPr/>
           <p:nvPr/>
         </p:nvSpPr>
@@ -3464,12 +3474,12 @@
   </p:cSld>
   <mc:AlternateContent>
     <mc:Choice Requires="p14">
-      <p:transition xmlns:p14="http://schemas.microsoft.com/office/powerpoint/2010/main">
-        <p14:reveal/>
+      <p:transition xmlns:p14="http://schemas.microsoft.com/office/powerpoint/2010/main" advTm="5000">
+        <p14:reveal dir="l"/>
       </p:transition>
     </mc:Choice>
     <mc:Fallback>
-      <p:transition>
+      <p:transition advTm="5000">
         <p:fade/>
       </p:transition>
     </mc:Fallback>
@@ -3508,7 +3518,7 @@
                                           </p:stCondLst>
                                         </p:cTn>
                                         <p:tgtEl>
-                                          <p:spTgt spid="10035"/>
+                                          <p:spTgt spid="100035"/>
                                         </p:tgtEl>
                                         <p:attrNameLst>
                                           <p:attrName>style.visibility</p:attrName>
@@ -3522,7 +3532,7 @@
                                       <p:cBhvr>
                                         <p:cTn id="5" dur="500"/>
                                         <p:tgtEl>
-                                          <p:spTgt spid="10035"/>
+                                          <p:spTgt spid="100035"/>
                                         </p:tgtEl>
                                       </p:cBhvr>
                                     </p:animEffect>
@@ -3561,7 +3571,7 @@
                                           </p:stCondLst>
                                         </p:cTn>
                                         <p:tgtEl>
-                                          <p:spTgt spid="10036"/>
+                                          <p:spTgt spid="100036"/>
                                         </p:tgtEl>
                                         <p:attrNameLst>
                                           <p:attrName>style.visibility</p:attrName>
@@ -3575,7 +3585,7 @@
                                       <p:cBhvr additive="base">
                                         <p:cTn id="13" dur="500" fill="hold"/>
                                         <p:tgtEl>
-                                          <p:spTgt spid="10036"/>
+                                          <p:spTgt spid="100036"/>
                                         </p:tgtEl>
                                         <p:attrNameLst>
                                           <p:attrName>ppt_y</p:attrName>
@@ -3620,7 +3630,7 @@
                                           </p:stCondLst>
                                         </p:cTn>
                                         <p:tgtEl>
-                                          <p:spTgt spid="10037"/>
+                                          <p:spTgt spid="100037"/>
                                         </p:tgtEl>
                                         <p:attrNameLst>
                                           <p:attrName>style.visibility</p:attrName>
@@ -3634,7 +3644,7 @@
                                       <p:cBhvr>
                                         <p:cTn id="18" dur="500" fill="hold"/>
                                         <p:tgtEl>
-                                          <p:spTgt spid="10037"/>
+                                          <p:spTgt spid="100037"/>
                                         </p:tgtEl>
                                       </p:cBhvr>
                                       <p:from x="0" y="0"/>
@@ -3675,7 +3685,7 @@
                                           </p:stCondLst>
                                         </p:cTn>
                                         <p:tgtEl>
-                                          <p:spTgt spid="10038"/>
+                                          <p:spTgt spid="100038"/>
                                         </p:tgtEl>
                                         <p:attrNameLst>
                                           <p:attrName>style.visibility</p:attrName>
@@ -3689,7 +3699,7 @@
                                       <p:cBhvr>
                                         <p:cTn id="23" dur="2000"/>
                                         <p:tgtEl>
-                                          <p:spTgt spid="10038"/>
+                                          <p:spTgt spid="100038"/>
                                         </p:tgtEl>
                                       </p:cBhvr>
                                     </p:animEffect>
@@ -3728,7 +3738,7 @@
                                           </p:stCondLst>
                                         </p:cTn>
                                         <p:tgtEl>
-                                          <p:spTgt spid="10039"/>
+                                          <p:spTgt spid="100039"/>
                                         </p:tgtEl>
                                         <p:attrNameLst>
                                           <p:attrName>style.visibility</p:attrName>
@@ -3742,7 +3752,7 @@
                                       <p:cBhvr>
                                         <p:cTn id="29" dur="200"/>
                                         <p:tgtEl>
-                                          <p:spTgt spid="10039"/>
+                                          <p:spTgt spid="100039"/>
                                         </p:tgtEl>
                                       </p:cBhvr>
                                     </p:animEffect>
@@ -3777,14 +3787,13 @@
       </p:par>
     </p:tnLst>
     <p:bldLst>
-      <p:bldP spid="10035" grpId="0"/>
-      <p:bldP spid="10036" grpId="1"/>
-      <p:bldP spid="10037" grpId="2"/>
-      <p:bldP spid="10038" grpId="3"/>
-      <p:bldP spid="10039" grpId="4"/>
+      <p:bldP spid="100035" grpId="0"/>
+      <p:bldP spid="100036" grpId="1"/>
+      <p:bldP spid="100037" grpId="2"/>
+      <p:bldP spid="100038" grpId="3"/>
+      <p:bldP spid="100039" grpId="4"/>
     </p:bldLst>
   </p:timing>
-  <p:transition advTm="5000"/>
 </p:sld>
 </file>
 

</xml_diff>